<commit_message>
Scope Review 2 report and deck to Review 2 criteria
Remove dashboard/reports, theme and web-security material (Review 3 topics);
keep schema, constraints, sample data, queries, PL/SQL objects, connectivity,
CRUD/transactions, tests. 76 passed offline, 16 live Oracle tests BLOCKED.

Co-Authored-By: Claude Sonnet 5.5 <noreply@anthropic.com>
Claude-Session: https://claude.ai/code/session_01VtiD3sYzdwe2Z45NHChjBt
</commit_message>
<xml_diff>
--- a/docs/Review_2_Presentation.pptx
+++ b/docs/Review_2_Presentation.pptx
@@ -5825,7 +5825,7 @@
                 </a:solidFill>
                 <a:latin typeface="Calibri"/>
               </a:rPr>
-              <a:t>Also passed: compile check, JS syntax, SQL syntax parse (queries + seed), Chromium page-render check</a:t>
+              <a:t>Also passed: Python compile check and SQL syntax parse of the 16 queries and the seed script</a:t>
             </a:r>
           </a:p>
         </p:txBody>
@@ -6819,7 +6819,7 @@
                 </a:solidFill>
                 <a:latin typeface="Calibri"/>
               </a:rPr>
-              <a:t>Delivered: normalized 7-table Oracle design, seed data, 16 queries, 4 PL/SQL-side objects, secure Flask service layer, atomic sales, cyberpunk UI, tests and report</a:t>
+              <a:t>Delivered: normalized 7-table Oracle design, seed data, 16 queries, 4 PL/SQL-side objects, secure Flask service layer, CRUD, atomic sales, tests and report</a:t>
             </a:r>
           </a:p>
           <a:p>
@@ -7080,7 +7080,7 @@
                 </a:solidFill>
                 <a:latin typeface="Calibri"/>
               </a:rPr>
-              <a:t>Screenshots of the real templates (sample data) and honest 503 page</a:t>
+              <a:t>Screenshots of the real CRUD / sale templates (sample data) and honest 503 page</a:t>
             </a:r>
           </a:p>
         </p:txBody>
@@ -8543,7 +8543,7 @@
                 </a:solidFill>
                 <a:latin typeface="Calibri"/>
               </a:rPr>
-              <a:t>HTML5 · CSS3 · vanilla JS · cyberpunk theme (dark / light)</a:t>
+              <a:t>HTML5 · CSS3 · vanilla JS · Jinja2 CRUD forms</a:t>
             </a:r>
           </a:p>
         </p:txBody>
@@ -8704,7 +8704,7 @@
                 </a:solidFill>
                 <a:latin typeface="Calibri"/>
               </a:rPr>
-              <a:t>25 routes · CSRF tokens · security headers · safe error pages</a:t>
+              <a:t>routes for CRUD, sales and health · safe error pages</a:t>
             </a:r>
           </a:p>
         </p:txBody>
@@ -8865,7 +8865,7 @@
                 </a:solidFill>
                 <a:latin typeface="Calibri"/>
               </a:rPr>
-              <a:t>validation · CRUD · sales transaction · reports — bind variables only</a:t>
+              <a:t>validation · CRUD · sales transaction — bind variables only</a:t>
             </a:r>
           </a:p>
         </p:txBody>
@@ -15456,7 +15456,7 @@
                 </a:solidFill>
                 <a:latin typeface="Calibri"/>
               </a:rPr>
-              <a:t>CRUD: products, categories, suppliers, customers + search, filters, pagination</a:t>
+              <a:t>CRUD: products, categories, suppliers, customers (+ sales and restock)</a:t>
             </a:r>
           </a:p>
         </p:txBody>
@@ -15883,7 +15883,7 @@
                 </a:solidFill>
                 <a:latin typeface="Calibri"/>
               </a:rPr>
-              <a:t>Application UI &amp; key workflows</a:t>
+              <a:t>CRUD screens &amp; sales workflow</a:t>
             </a:r>
           </a:p>
         </p:txBody>
@@ -15961,7 +15961,7 @@
                 </a:solidFill>
                 <a:latin typeface="Calibri"/>
               </a:rPr>
-              <a:t>Cyberpunk theme · dark default + light palette</a:t>
+              <a:t>Real Flask routes and templates · sample data</a:t>
             </a:r>
           </a:p>
         </p:txBody>
@@ -16038,7 +16038,7 @@
       </p:sp>
       <p:pic>
         <p:nvPicPr>
-          <p:cNvPr id="8" name="Picture 7" descr="ui_dashboard.png"/>
+          <p:cNvPr id="8" name="Picture 7" descr="ui_products_crop.png"/>
           <p:cNvPicPr>
             <a:picLocks noChangeAspect="1"/>
           </p:cNvPicPr>
@@ -16114,7 +16114,7 @@
                 </a:solidFill>
                 <a:latin typeface="Calibri"/>
               </a:rPr>
-              <a:t>Dashboard</a:t>
+              <a:t>Products: create / edit / delete / restock</a:t>
             </a:r>
           </a:p>
         </p:txBody>
@@ -16197,7 +16197,7 @@
                 </a:solidFill>
                 <a:latin typeface="Calibri"/>
               </a:rPr>
-              <a:t>Workflow: add/edit master data → New Sale → invoice page → stock falls once → Reports</a:t>
+              <a:t>Workflow: add / edit master data → New Sale → invoice page → stock falls exactly once</a:t>
             </a:r>
           </a:p>
           <a:p>
@@ -16222,7 +16222,7 @@
                 </a:solidFill>
                 <a:latin typeface="Calibri"/>
               </a:rPr>
-              <a:t>Delete confirmation, CSRF on every POST, empty / error / 503 states, responsive layout</a:t>
+              <a:t>Invalid input, missing references and referenced-row deletes return clear 400 / 404 / 409 messages</a:t>
             </a:r>
           </a:p>
         </p:txBody>

</xml_diff>

<commit_message>
Docs: record live Oracle 21c XE results; tidy queries.sql column formats
Review 2 report, DOCX/PDF and deck now show 16/16 live integration tests and
16/16 queries run by the student on 2026-10-22. Results were transcribed from
the student's console output (provenance stated in the report).

Co-Authored-By: Claude Sonnet 5.5 <noreply@anthropic.com>
Claude-Session: https://claude.ai/code/session_01VtiD3sYzdwe2Z45NHChjBt
</commit_message>
<xml_diff>
--- a/docs/Review_2_Presentation.pptx
+++ b/docs/Review_2_Presentation.pptx
@@ -583,7 +583,7 @@
           <a:lstStyle/>
           <a:p>
             <a:r>
-              <a:t>Do not claim database verification. The BLOCKED tests are the ones that prove constraints, PL/SQL objects and concurrency on a real Oracle.</a:t>
+              <a:t>The live tests ran on a separate test schema on Oracle 21c XE and prove constraints, PL/SQL objects and concurrency. Results were transcribed from the student's console output.</a:t>
             </a:r>
           </a:p>
         </p:txBody>
@@ -1143,7 +1143,7 @@
           <a:lstStyle/>
           <a:p>
             <a:r>
-              <a:t>Syntax-checked statically (sqlglot, Oracle dialect) for the queries; live execution on Oracle is pending — state this plainly.</a:t>
+              <a:t>Syntax-checked statically (sqlglot, Oracle dialect) for the queries; all 16 also executed live on Oracle 21c XE without error.</a:t>
             </a:r>
           </a:p>
         </p:txBody>
@@ -1213,7 +1213,7 @@
           <a:lstStyle/>
           <a:p>
             <a:r>
-              <a:t>Live concurrency proof (8 buyers, stock 5 -&gt; exactly 5 succeed) is an integration test that needs Oracle: BLOCKED here.</a:t>
+              <a:t>Live concurrency proof (8 buyers, stock 5 -&gt; exactly 5 succeed) PASSED on Oracle 21c XE.</a:t>
             </a:r>
           </a:p>
         </p:txBody>
@@ -4971,7 +4971,7 @@
                 </a:solidFill>
                 <a:latin typeface="Calibri"/>
               </a:rPr>
-              <a:t>76</a:t>
+              <a:t>92</a:t>
             </a:r>
           </a:p>
         </p:txBody>
@@ -5089,7 +5089,7 @@
                 </a:solidFill>
                 <a:latin typeface="Calibri"/>
               </a:rPr>
-              <a:t>16</a:t>
+              <a:t>0</a:t>
             </a:r>
           </a:p>
         </p:txBody>
@@ -5713,11 +5713,11 @@
                       <a:r>
                         <a:rPr sz="1400" b="0">
                           <a:solidFill>
-                            <a:srgbClr val="FFB300"/>
+                            <a:srgbClr val="E8EEF8"/>
                           </a:solidFill>
                           <a:latin typeface="Calibri"/>
                         </a:rPr>
-                        <a:t>16 BLOCKED</a:t>
+                        <a:t>16 PASSED</a:t>
                       </a:r>
                     </a:p>
                   </a:txBody>
@@ -5775,7 +5775,7 @@
                 </a:solidFill>
                 <a:latin typeface="Calibri"/>
               </a:rPr>
-              <a:t>76 offline tests passed using a FAKE database connection: they prove application logic, not Oracle behaviour</a:t>
+              <a:t>92 offline tests passed using a FAKE database connection: they prove application logic, not Oracle behaviour</a:t>
             </a:r>
           </a:p>
           <a:p>
@@ -5800,7 +5800,7 @@
                 </a:solidFill>
                 <a:latin typeface="Calibri"/>
               </a:rPr>
-              <a:t>16 live Oracle integration tests are BLOCKED / unverified — no Oracle instance was available; they are ready to run (README §9)</a:t>
+              <a:t>16 live Oracle integration tests PASSED on Oracle 21c XE (student run, 2026-10-22); all 16 queries also ran live without error</a:t>
             </a:r>
           </a:p>
           <a:p>
@@ -6173,7 +6173,7 @@
                 </a:solidFill>
                 <a:latin typeface="Calibri"/>
               </a:rPr>
-              <a:t>Not yet run against a live Oracle instance (16 tests BLOCKED)</a:t>
+              <a:t>Live results come from one single-user run on one machine</a:t>
             </a:r>
           </a:p>
           <a:p>
@@ -6844,7 +6844,7 @@
                 </a:solidFill>
                 <a:latin typeface="Calibri"/>
               </a:rPr>
-              <a:t>Every claim above is backed by files in the repository; unverified items are labelled BLOCKED</a:t>
+              <a:t>Every claim above is backed by files in the repository; live Oracle results are labelled as a student run</a:t>
             </a:r>
           </a:p>
         </p:txBody>
@@ -7106,7 +7106,7 @@
           </a:solidFill>
           <a:ln w="12700">
             <a:solidFill>
-              <a:srgbClr val="FFB300"/>
+              <a:srgbClr val="00E676"/>
             </a:solidFill>
           </a:ln>
           <a:effectLst/>
@@ -7159,11 +7159,11 @@
             <a:r>
               <a:rPr sz="1500" b="1">
                 <a:solidFill>
-                  <a:srgbClr val="FFB300"/>
-                </a:solidFill>
-                <a:latin typeface="Calibri"/>
-              </a:rPr>
-              <a:t>TO DO</a:t>
+                  <a:srgbClr val="00E676"/>
+                </a:solidFill>
+                <a:latin typeface="Calibri"/>
+              </a:rPr>
+              <a:t>DONE</a:t>
             </a:r>
           </a:p>
         </p:txBody>
@@ -7198,7 +7198,7 @@
                 </a:solidFill>
                 <a:latin typeface="Calibri"/>
               </a:rPr>
-              <a:t>Run schema.sql → advanced_features.sql → seed.sql in XEPDB1 as appliance_app</a:t>
+              <a:t>schema.sql → advanced_features.sql → seed.sql loaded in XEPDB1; 16 queries ran live</a:t>
             </a:r>
           </a:p>
         </p:txBody>
@@ -7212,6 +7212,124 @@
         <p:spPr>
           <a:xfrm>
             <a:off x="548640" y="4480560"/>
+            <a:ext cx="11109960" cy="594360"/>
+          </a:xfrm>
+          <a:prstGeom prst="roundRect">
+            <a:avLst>
+              <a:gd name="adj" fmla="val 10000"/>
+            </a:avLst>
+          </a:prstGeom>
+          <a:solidFill>
+            <a:srgbClr val="141B33"/>
+          </a:solidFill>
+          <a:ln w="12700">
+            <a:solidFill>
+              <a:srgbClr val="00E676"/>
+            </a:solidFill>
+          </a:ln>
+          <a:effectLst/>
+        </p:spPr>
+        <p:style>
+          <a:lnRef idx="1">
+            <a:schemeClr val="accent1"/>
+          </a:lnRef>
+          <a:fillRef idx="3">
+            <a:schemeClr val="accent1"/>
+          </a:fillRef>
+          <a:effectRef idx="2">
+            <a:schemeClr val="accent1"/>
+          </a:effectRef>
+          <a:fontRef idx="minor">
+            <a:schemeClr val="lt1"/>
+          </a:fontRef>
+        </p:style>
+        <p:txBody>
+          <a:bodyPr rtlCol="0" anchor="ctr"/>
+          <a:lstStyle/>
+          <a:p>
+            <a:pPr algn="ctr"/>
+          </a:p>
+        </p:txBody>
+      </p:sp>
+      <p:sp>
+        <p:nvSpPr>
+          <p:cNvPr id="18" name="TextBox 17"/>
+          <p:cNvSpPr txBox="1"/>
+          <p:nvPr/>
+        </p:nvSpPr>
+        <p:spPr>
+          <a:xfrm>
+            <a:off x="685800" y="4526280"/>
+            <a:ext cx="1005840" cy="502920"/>
+          </a:xfrm>
+          <a:prstGeom prst="rect">
+            <a:avLst/>
+          </a:prstGeom>
+          <a:noFill/>
+        </p:spPr>
+        <p:txBody>
+          <a:bodyPr wrap="square" anchor="ctr" lIns="45720" rIns="45720" tIns="27432" bIns="27432">
+            <a:spAutoFit/>
+          </a:bodyPr>
+          <a:lstStyle/>
+          <a:p>
+            <a:pPr algn="l"/>
+            <a:r>
+              <a:rPr sz="1500" b="1">
+                <a:solidFill>
+                  <a:srgbClr val="00E676"/>
+                </a:solidFill>
+                <a:latin typeface="Calibri"/>
+              </a:rPr>
+              <a:t>DONE</a:t>
+            </a:r>
+          </a:p>
+        </p:txBody>
+      </p:sp>
+      <p:sp>
+        <p:nvSpPr>
+          <p:cNvPr id="19" name="TextBox 18"/>
+          <p:cNvSpPr txBox="1"/>
+          <p:nvPr/>
+        </p:nvSpPr>
+        <p:spPr>
+          <a:xfrm>
+            <a:off x="1783080" y="4526280"/>
+            <a:ext cx="9784080" cy="502920"/>
+          </a:xfrm>
+          <a:prstGeom prst="rect">
+            <a:avLst/>
+          </a:prstGeom>
+          <a:noFill/>
+        </p:spPr>
+        <p:txBody>
+          <a:bodyPr wrap="square" anchor="ctr" lIns="45720" rIns="45720" tIns="27432" bIns="27432">
+            <a:spAutoFit/>
+          </a:bodyPr>
+          <a:lstStyle/>
+          <a:p>
+            <a:pPr algn="l"/>
+            <a:r>
+              <a:rPr sz="1500" b="0">
+                <a:solidFill>
+                  <a:srgbClr val="E8EEF8"/>
+                </a:solidFill>
+                <a:latin typeface="Calibri"/>
+              </a:rPr>
+              <a:t>16 live integration tests PASSED on Oracle 21c XE (separate test schema)</a:t>
+            </a:r>
+          </a:p>
+        </p:txBody>
+      </p:sp>
+      <p:sp>
+        <p:nvSpPr>
+          <p:cNvPr id="20" name="Rounded Rectangle 19"/>
+          <p:cNvSpPr/>
+          <p:nvPr/>
+        </p:nvSpPr>
+        <p:spPr>
+          <a:xfrm>
+            <a:off x="548640" y="5166360"/>
             <a:ext cx="11109960" cy="594360"/>
           </a:xfrm>
           <a:prstGeom prst="roundRect">
@@ -7253,13 +7371,13 @@
       </p:sp>
       <p:sp>
         <p:nvSpPr>
-          <p:cNvPr id="18" name="TextBox 17"/>
+          <p:cNvPr id="21" name="TextBox 20"/>
           <p:cNvSpPr txBox="1"/>
           <p:nvPr/>
         </p:nvSpPr>
         <p:spPr>
           <a:xfrm>
-            <a:off x="685800" y="4526280"/>
+            <a:off x="685800" y="5212080"/>
             <a:ext cx="1005840" cy="502920"/>
           </a:xfrm>
           <a:prstGeom prst="rect">
@@ -7288,13 +7406,13 @@
       </p:sp>
       <p:sp>
         <p:nvSpPr>
-          <p:cNvPr id="19" name="TextBox 18"/>
+          <p:cNvPr id="22" name="TextBox 21"/>
           <p:cNvSpPr txBox="1"/>
           <p:nvPr/>
         </p:nvSpPr>
         <p:spPr>
           <a:xfrm>
-            <a:off x="1783080" y="4526280"/>
+            <a:off x="1783080" y="5212080"/>
             <a:ext cx="9784080" cy="502920"/>
           </a:xfrm>
           <a:prstGeom prst="rect">
@@ -7316,124 +7434,6 @@
                 </a:solidFill>
                 <a:latin typeface="Calibri"/>
               </a:rPr>
-              <a:t>python -m services.database  then the live integration tests (separate test schema)</a:t>
-            </a:r>
-          </a:p>
-        </p:txBody>
-      </p:sp>
-      <p:sp>
-        <p:nvSpPr>
-          <p:cNvPr id="20" name="Rounded Rectangle 19"/>
-          <p:cNvSpPr/>
-          <p:nvPr/>
-        </p:nvSpPr>
-        <p:spPr>
-          <a:xfrm>
-            <a:off x="548640" y="5166360"/>
-            <a:ext cx="11109960" cy="594360"/>
-          </a:xfrm>
-          <a:prstGeom prst="roundRect">
-            <a:avLst>
-              <a:gd name="adj" fmla="val 10000"/>
-            </a:avLst>
-          </a:prstGeom>
-          <a:solidFill>
-            <a:srgbClr val="141B33"/>
-          </a:solidFill>
-          <a:ln w="12700">
-            <a:solidFill>
-              <a:srgbClr val="FFB300"/>
-            </a:solidFill>
-          </a:ln>
-          <a:effectLst/>
-        </p:spPr>
-        <p:style>
-          <a:lnRef idx="1">
-            <a:schemeClr val="accent1"/>
-          </a:lnRef>
-          <a:fillRef idx="3">
-            <a:schemeClr val="accent1"/>
-          </a:fillRef>
-          <a:effectRef idx="2">
-            <a:schemeClr val="accent1"/>
-          </a:effectRef>
-          <a:fontRef idx="minor">
-            <a:schemeClr val="lt1"/>
-          </a:fontRef>
-        </p:style>
-        <p:txBody>
-          <a:bodyPr rtlCol="0" anchor="ctr"/>
-          <a:lstStyle/>
-          <a:p>
-            <a:pPr algn="ctr"/>
-          </a:p>
-        </p:txBody>
-      </p:sp>
-      <p:sp>
-        <p:nvSpPr>
-          <p:cNvPr id="21" name="TextBox 20"/>
-          <p:cNvSpPr txBox="1"/>
-          <p:nvPr/>
-        </p:nvSpPr>
-        <p:spPr>
-          <a:xfrm>
-            <a:off x="685800" y="5212080"/>
-            <a:ext cx="1005840" cy="502920"/>
-          </a:xfrm>
-          <a:prstGeom prst="rect">
-            <a:avLst/>
-          </a:prstGeom>
-          <a:noFill/>
-        </p:spPr>
-        <p:txBody>
-          <a:bodyPr wrap="square" anchor="ctr" lIns="45720" rIns="45720" tIns="27432" bIns="27432">
-            <a:spAutoFit/>
-          </a:bodyPr>
-          <a:lstStyle/>
-          <a:p>
-            <a:pPr algn="l"/>
-            <a:r>
-              <a:rPr sz="1500" b="1">
-                <a:solidFill>
-                  <a:srgbClr val="FFB300"/>
-                </a:solidFill>
-                <a:latin typeface="Calibri"/>
-              </a:rPr>
-              <a:t>TO DO</a:t>
-            </a:r>
-          </a:p>
-        </p:txBody>
-      </p:sp>
-      <p:sp>
-        <p:nvSpPr>
-          <p:cNvPr id="22" name="TextBox 21"/>
-          <p:cNvSpPr txBox="1"/>
-          <p:nvPr/>
-        </p:nvSpPr>
-        <p:spPr>
-          <a:xfrm>
-            <a:off x="1783080" y="5212080"/>
-            <a:ext cx="9784080" cy="502920"/>
-          </a:xfrm>
-          <a:prstGeom prst="rect">
-            <a:avLst/>
-          </a:prstGeom>
-          <a:noFill/>
-        </p:spPr>
-        <p:txBody>
-          <a:bodyPr wrap="square" anchor="ctr" lIns="45720" rIns="45720" tIns="27432" bIns="27432">
-            <a:spAutoFit/>
-          </a:bodyPr>
-          <a:lstStyle/>
-          <a:p>
-            <a:pPr algn="l"/>
-            <a:r>
-              <a:rPr sz="1500" b="0">
-                <a:solidFill>
-                  <a:srgbClr val="E8EEF8"/>
-                </a:solidFill>
-                <a:latin typeface="Calibri"/>
-              </a:rPr>
               <a:t>Rehearse docs/demo_guide.md (10 minutes); regenerate report matrix after live run</a:t>
             </a:r>
           </a:p>
@@ -7469,7 +7469,7 @@
                 </a:solidFill>
                 <a:latin typeface="Calibri"/>
               </a:rPr>
-              <a:t>Demonstration readiness: ready once the three live Oracle steps are completed on the presenter's machine.</a:t>
+              <a:t>Demonstration readiness: live Oracle steps completed; rehearse the demo guide before the review.</a:t>
             </a:r>
           </a:p>
         </p:txBody>

</xml_diff>